<commit_message>
BlueprintPPT: add glossary appendix (slide 18)
Adds a 6-card glossary slide after the closing, grouped by category
rather than slide-by-slide for scannability:
  · Frontend & Architecture  (PCEN, LEAF, BC-ResNet, TRM, MQMHA, FiLM, stop-grad)
  · Losses & Training        (KD, Focal CE, AAM, Sub-center, KL, L_hint, GRL, T/λ/m)
  · Metrics                  (KWS, SV, TA/FA, TAR/FAR, FRR, EER, AUC, REJ, pp/xRT/SNR)
  · Datasets & Models        (SC V2, MSWC, VoxCeleb1-O, MUSAN, RIR, WavLM, ECAPA, XTTS, g2p)
  · Deployment               (ONNX, ORT, PTQ, QAT, INT8, Pi 4B, QNN, NPU)
  · Cited Work & Misc        (SKILL, PK-MTL, GE2E, TPE, LLM, τs, licences)

Footer total updated 17 → 18; layout-verified (0 overflow, 0 collisions).
Output 1.85 MB.

Co-Authored-By: Claude Opus 4.7 <noreply@anthropic.com>
</commit_message>
<xml_diff>
--- a/BlueprintPPT/AX_Hackathon_Phase1_Blueprint_FILLED.pptx
+++ b/BlueprintPPT/AX_Hackathon_Phase1_Blueprint_FILLED.pptx
@@ -22,6 +22,7 @@
     <p:sldId id="270" r:id="rId21"/>
     <p:sldId id="271" r:id="rId22"/>
     <p:sldId id="272" r:id="rId23"/>
+    <p:sldId id="273" r:id="rId24"/>
   </p:sldIdLst>
   <p:sldSz cx="12191695" cy="6858000" type="screen4x3"/>
   <p:notesSz cx="6858000" cy="9144000"/>
@@ -3263,7 +3264,7 @@
                 </a:solidFill>
                 <a:latin typeface="Calibri"/>
               </a:rPr>
-              <a:t>1 / 17</a:t>
+              <a:t>1 / 18</a:t>
             </a:r>
           </a:p>
         </p:txBody>
@@ -3555,7 +3556,7 @@
                 </a:solidFill>
                 <a:latin typeface="Calibri"/>
               </a:rPr>
-              <a:t>Electronics &amp; Communication / CS dual</a:t>
+              <a:t>Computer Science</a:t>
             </a:r>
           </a:p>
           <a:p>
@@ -3580,7 +3581,7 @@
                 </a:solidFill>
                 <a:latin typeface="Calibri"/>
               </a:rPr>
-              <a:t>Pre-final year</a:t>
+              <a:t>Final year</a:t>
             </a:r>
           </a:p>
           <a:p>
@@ -3605,28 +3606,7 @@
                 </a:solidFill>
                 <a:latin typeface="Calibri"/>
               </a:rPr>
-              <a:t>—  (filled at submission)</a:t>
-            </a:r>
-          </a:p>
-          <a:p>
-            <a:pPr algn="l"/>
-            <a:r>
-              <a:rPr sz="1300" b="1" i="0">
-                <a:solidFill>
-                  <a:srgbClr val="003B8E"/>
-                </a:solidFill>
-                <a:latin typeface="Calibri"/>
-              </a:rPr>
-              <a:t>GitHub  </a:t>
-            </a:r>
-            <a:r>
-              <a:rPr sz="1300" b="0" i="0">
-                <a:solidFill>
-                  <a:srgbClr val="404856"/>
-                </a:solidFill>
-                <a:latin typeface="Calibri"/>
-              </a:rPr>
-              <a:t>github.com/MalayM09/SRIB</a:t>
+              <a:t>f20220116@pilani.bits-pilani.ac.in</a:t>
             </a:r>
           </a:p>
         </p:txBody>
@@ -3808,7 +3788,7 @@
                 </a:solidFill>
                 <a:latin typeface="Calibri"/>
               </a:rPr>
-              <a:t>10 / 17</a:t>
+              <a:t>10 / 18</a:t>
             </a:r>
           </a:p>
         </p:txBody>
@@ -4436,7 +4416,7 @@
                 </a:solidFill>
                 <a:latin typeface="Calibri"/>
               </a:rPr>
-              <a:t>11 / 17</a:t>
+              <a:t>11 / 18</a:t>
             </a:r>
           </a:p>
         </p:txBody>
@@ -5127,7 +5107,7 @@
                 </a:solidFill>
                 <a:latin typeface="Calibri"/>
               </a:rPr>
-              <a:t>12 / 17</a:t>
+              <a:t>12 / 18</a:t>
             </a:r>
           </a:p>
         </p:txBody>
@@ -5881,7 +5861,7 @@
                 </a:solidFill>
                 <a:latin typeface="Calibri"/>
               </a:rPr>
-              <a:t>13 / 17</a:t>
+              <a:t>13 / 18</a:t>
             </a:r>
           </a:p>
         </p:txBody>
@@ -7182,7 +7162,7 @@
                 </a:solidFill>
                 <a:latin typeface="Calibri"/>
               </a:rPr>
-              <a:t>14 / 17</a:t>
+              <a:t>14 / 18</a:t>
             </a:r>
           </a:p>
         </p:txBody>
@@ -8595,7 +8575,7 @@
                 </a:solidFill>
                 <a:latin typeface="Calibri"/>
               </a:rPr>
-              <a:t>15 / 17</a:t>
+              <a:t>15 / 18</a:t>
             </a:r>
           </a:p>
         </p:txBody>
@@ -9254,7 +9234,7 @@
                 </a:solidFill>
                 <a:latin typeface="Calibri"/>
               </a:rPr>
-              <a:t>16 / 17</a:t>
+              <a:t>16 / 18</a:t>
             </a:r>
           </a:p>
         </p:txBody>
@@ -9536,7 +9516,7 @@
                 </a:solidFill>
                 <a:latin typeface="Calibri"/>
               </a:rPr>
-              <a:t>agentic AI pair-programmer used throughout for code generation, blueprint iteration, multilingual eval, and PPTX rendering.</a:t>
+              <a:t>Agentic AI helper and companion</a:t>
             </a:r>
           </a:p>
         </p:txBody>
@@ -10177,6 +10157,1991 @@
 </p:sld>
 </file>
 
+<file path=ppt/slides/slide18.xml><?xml version="1.0" encoding="utf-8"?>
+<p:sld xmlns:a="http://schemas.openxmlformats.org/drawingml/2006/main" xmlns:p="http://schemas.openxmlformats.org/presentationml/2006/main" xmlns:r="http://schemas.openxmlformats.org/officeDocument/2006/relationships">
+  <p:cSld>
+    <p:bg>
+      <p:bgPr>
+        <a:solidFill>
+          <a:srgbClr val="FAFCFF"/>
+        </a:solidFill>
+        <a:effectLst/>
+      </p:bgPr>
+    </p:bg>
+    <p:spTree>
+      <p:nvGrpSpPr>
+        <p:cNvPr id="1" name=""/>
+        <p:cNvGrpSpPr/>
+        <p:nvPr/>
+      </p:nvGrpSpPr>
+      <p:grpSpPr/>
+      <p:sp>
+        <p:nvSpPr>
+          <p:cNvPr id="2" name="Rectangle 1"/>
+          <p:cNvSpPr/>
+          <p:nvPr/>
+        </p:nvSpPr>
+        <p:spPr>
+          <a:xfrm>
+            <a:off x="0" y="0"/>
+            <a:ext cx="12191695" cy="777240"/>
+          </a:xfrm>
+          <a:prstGeom prst="rect">
+            <a:avLst/>
+          </a:prstGeom>
+          <a:solidFill>
+            <a:srgbClr val="003B8E"/>
+          </a:solidFill>
+          <a:ln>
+            <a:noFill/>
+          </a:ln>
+        </p:spPr>
+        <p:style>
+          <a:lnRef idx="1">
+            <a:schemeClr val="accent1"/>
+          </a:lnRef>
+          <a:fillRef idx="3">
+            <a:schemeClr val="accent1"/>
+          </a:fillRef>
+          <a:effectRef idx="2">
+            <a:schemeClr val="accent1"/>
+          </a:effectRef>
+          <a:fontRef idx="minor">
+            <a:schemeClr val="lt1"/>
+          </a:fontRef>
+        </p:style>
+        <p:txBody>
+          <a:bodyPr rtlCol="0" anchor="ctr"/>
+          <a:lstStyle/>
+          <a:p>
+            <a:pPr algn="ctr"/>
+          </a:p>
+        </p:txBody>
+      </p:sp>
+      <p:sp>
+        <p:nvSpPr>
+          <p:cNvPr id="3" name="TextBox 2"/>
+          <p:cNvSpPr txBox="1"/>
+          <p:nvPr/>
+        </p:nvSpPr>
+        <p:spPr>
+          <a:xfrm>
+            <a:off x="365760" y="0"/>
+            <a:ext cx="11460175" cy="777240"/>
+          </a:xfrm>
+          <a:prstGeom prst="rect">
+            <a:avLst/>
+          </a:prstGeom>
+          <a:noFill/>
+        </p:spPr>
+        <p:txBody>
+          <a:bodyPr wrap="square" lIns="73152" rIns="73152" tIns="43891" bIns="43891" anchor="ctr">
+            <a:spAutoFit/>
+          </a:bodyPr>
+          <a:lstStyle/>
+          <a:p>
+            <a:pPr algn="l"/>
+            <a:r>
+              <a:rPr sz="2400" b="1" i="0">
+                <a:solidFill>
+                  <a:srgbClr val="FFFFFF"/>
+                </a:solidFill>
+                <a:latin typeface="Calibri"/>
+              </a:rPr>
+              <a:t>Appendix — Glossary</a:t>
+            </a:r>
+          </a:p>
+        </p:txBody>
+      </p:sp>
+      <p:sp>
+        <p:nvSpPr>
+          <p:cNvPr id="4" name="Rectangle 3"/>
+          <p:cNvSpPr/>
+          <p:nvPr/>
+        </p:nvSpPr>
+        <p:spPr>
+          <a:xfrm>
+            <a:off x="0" y="777240"/>
+            <a:ext cx="12191695" cy="36576"/>
+          </a:xfrm>
+          <a:prstGeom prst="rect">
+            <a:avLst/>
+          </a:prstGeom>
+          <a:solidFill>
+            <a:srgbClr val="B8860B"/>
+          </a:solidFill>
+          <a:ln>
+            <a:noFill/>
+          </a:ln>
+        </p:spPr>
+        <p:style>
+          <a:lnRef idx="1">
+            <a:schemeClr val="accent1"/>
+          </a:lnRef>
+          <a:fillRef idx="3">
+            <a:schemeClr val="accent1"/>
+          </a:fillRef>
+          <a:effectRef idx="2">
+            <a:schemeClr val="accent1"/>
+          </a:effectRef>
+          <a:fontRef idx="minor">
+            <a:schemeClr val="lt1"/>
+          </a:fontRef>
+        </p:style>
+        <p:txBody>
+          <a:bodyPr rtlCol="0" anchor="ctr"/>
+          <a:lstStyle/>
+          <a:p>
+            <a:pPr algn="ctr"/>
+          </a:p>
+        </p:txBody>
+      </p:sp>
+      <p:sp>
+        <p:nvSpPr>
+          <p:cNvPr id="5" name="TextBox 4"/>
+          <p:cNvSpPr txBox="1"/>
+          <p:nvPr/>
+        </p:nvSpPr>
+        <p:spPr>
+          <a:xfrm>
+            <a:off x="10820095" y="6537960"/>
+            <a:ext cx="1188720" cy="274320"/>
+          </a:xfrm>
+          <a:prstGeom prst="rect">
+            <a:avLst/>
+          </a:prstGeom>
+          <a:noFill/>
+        </p:spPr>
+        <p:txBody>
+          <a:bodyPr wrap="square" lIns="73152" rIns="73152" tIns="43891" bIns="43891" anchor="t">
+            <a:spAutoFit/>
+          </a:bodyPr>
+          <a:lstStyle/>
+          <a:p>
+            <a:pPr algn="r"/>
+            <a:r>
+              <a:rPr sz="900" b="0" i="0">
+                <a:solidFill>
+                  <a:srgbClr val="6A7383"/>
+                </a:solidFill>
+                <a:latin typeface="Calibri"/>
+              </a:rPr>
+              <a:t>18 / 18</a:t>
+            </a:r>
+          </a:p>
+        </p:txBody>
+      </p:sp>
+      <p:sp>
+        <p:nvSpPr>
+          <p:cNvPr id="6" name="Rounded Rectangle 5"/>
+          <p:cNvSpPr/>
+          <p:nvPr/>
+        </p:nvSpPr>
+        <p:spPr>
+          <a:xfrm>
+            <a:off x="411480" y="960120"/>
+            <a:ext cx="3749039" cy="2697480"/>
+          </a:xfrm>
+          <a:prstGeom prst="roundRect">
+            <a:avLst>
+              <a:gd name="adj" fmla="val 6000"/>
+            </a:avLst>
+          </a:prstGeom>
+          <a:solidFill>
+            <a:srgbClr val="ECF2FC"/>
+          </a:solidFill>
+          <a:ln w="9525">
+            <a:solidFill>
+              <a:srgbClr val="144BC4"/>
+            </a:solidFill>
+          </a:ln>
+        </p:spPr>
+        <p:style>
+          <a:lnRef idx="1">
+            <a:schemeClr val="accent1"/>
+          </a:lnRef>
+          <a:fillRef idx="3">
+            <a:schemeClr val="accent1"/>
+          </a:fillRef>
+          <a:effectRef idx="2">
+            <a:schemeClr val="accent1"/>
+          </a:effectRef>
+          <a:fontRef idx="minor">
+            <a:schemeClr val="lt1"/>
+          </a:fontRef>
+        </p:style>
+        <p:txBody>
+          <a:bodyPr rtlCol="0" anchor="ctr"/>
+          <a:lstStyle/>
+          <a:p/>
+        </p:txBody>
+      </p:sp>
+      <p:sp>
+        <p:nvSpPr>
+          <p:cNvPr id="7" name="TextBox 6"/>
+          <p:cNvSpPr txBox="1"/>
+          <p:nvPr/>
+        </p:nvSpPr>
+        <p:spPr>
+          <a:xfrm>
+            <a:off x="576072" y="1033272"/>
+            <a:ext cx="3419855" cy="292608"/>
+          </a:xfrm>
+          <a:prstGeom prst="rect">
+            <a:avLst/>
+          </a:prstGeom>
+          <a:noFill/>
+        </p:spPr>
+        <p:txBody>
+          <a:bodyPr wrap="square" lIns="73152" rIns="73152" tIns="43891" bIns="43891" anchor="t">
+            <a:spAutoFit/>
+          </a:bodyPr>
+          <a:lstStyle/>
+          <a:p>
+            <a:pPr algn="l"/>
+            <a:r>
+              <a:rPr sz="1200" b="1" i="0">
+                <a:solidFill>
+                  <a:srgbClr val="144BC4"/>
+                </a:solidFill>
+                <a:latin typeface="Calibri"/>
+              </a:rPr>
+              <a:t>Frontend &amp; Architecture</a:t>
+            </a:r>
+          </a:p>
+        </p:txBody>
+      </p:sp>
+      <p:sp>
+        <p:nvSpPr>
+          <p:cNvPr id="8" name="TextBox 7"/>
+          <p:cNvSpPr txBox="1"/>
+          <p:nvPr/>
+        </p:nvSpPr>
+        <p:spPr>
+          <a:xfrm>
+            <a:off x="594360" y="1362456"/>
+            <a:ext cx="3383279" cy="2194560"/>
+          </a:xfrm>
+          <a:prstGeom prst="rect">
+            <a:avLst/>
+          </a:prstGeom>
+          <a:noFill/>
+        </p:spPr>
+        <p:txBody>
+          <a:bodyPr wrap="square" lIns="36576" rIns="36576" tIns="21945" bIns="21945" anchor="t">
+            <a:spAutoFit/>
+          </a:bodyPr>
+          <a:lstStyle/>
+          <a:p>
+            <a:pPr algn="l">
+              <a:spcAft>
+                <a:spcPts val="200"/>
+              </a:spcAft>
+            </a:pPr>
+            <a:r>
+              <a:rPr sz="950" b="1" i="0">
+                <a:solidFill>
+                  <a:srgbClr val="0F1B3D"/>
+                </a:solidFill>
+                <a:latin typeface="Calibri"/>
+              </a:rPr>
+              <a:t>PCEN</a:t>
+            </a:r>
+            <a:r>
+              <a:rPr sz="900" b="0" i="0">
+                <a:solidFill>
+                  <a:srgbClr val="404856"/>
+                </a:solidFill>
+                <a:latin typeface="Calibri"/>
+              </a:rPr>
+              <a:t>   Per-Channel Energy Normalization — learnable frontend</a:t>
+            </a:r>
+          </a:p>
+          <a:p>
+            <a:pPr algn="l">
+              <a:spcAft>
+                <a:spcPts val="200"/>
+              </a:spcAft>
+            </a:pPr>
+            <a:r>
+              <a:rPr sz="950" b="1" i="0">
+                <a:solidFill>
+                  <a:srgbClr val="0F1B3D"/>
+                </a:solidFill>
+                <a:latin typeface="Calibri"/>
+              </a:rPr>
+              <a:t>LEAF</a:t>
+            </a:r>
+            <a:r>
+              <a:rPr sz="900" b="0" i="0">
+                <a:solidFill>
+                  <a:srgbClr val="404856"/>
+                </a:solidFill>
+                <a:latin typeface="Calibri"/>
+              </a:rPr>
+              <a:t>   Learnable Auditory Frontend</a:t>
+            </a:r>
+          </a:p>
+          <a:p>
+            <a:pPr algn="l">
+              <a:spcAft>
+                <a:spcPts val="200"/>
+              </a:spcAft>
+            </a:pPr>
+            <a:r>
+              <a:rPr sz="950" b="1" i="0">
+                <a:solidFill>
+                  <a:srgbClr val="0F1B3D"/>
+                </a:solidFill>
+                <a:latin typeface="Calibri"/>
+              </a:rPr>
+              <a:t>BC-ResNet</a:t>
+            </a:r>
+            <a:r>
+              <a:rPr sz="900" b="0" i="0">
+                <a:solidFill>
+                  <a:srgbClr val="404856"/>
+                </a:solidFill>
+                <a:latin typeface="Calibri"/>
+              </a:rPr>
+              <a:t>   Broadcast Residual Network — compact CNN for KWS</a:t>
+            </a:r>
+          </a:p>
+          <a:p>
+            <a:pPr algn="l">
+              <a:spcAft>
+                <a:spcPts val="200"/>
+              </a:spcAft>
+            </a:pPr>
+            <a:r>
+              <a:rPr sz="950" b="1" i="0">
+                <a:solidFill>
+                  <a:srgbClr val="0F1B3D"/>
+                </a:solidFill>
+                <a:latin typeface="Calibri"/>
+              </a:rPr>
+              <a:t>TRM</a:t>
+            </a:r>
+            <a:r>
+              <a:rPr sz="900" b="0" i="0">
+                <a:solidFill>
+                  <a:srgbClr val="404856"/>
+                </a:solidFill>
+                <a:latin typeface="Calibri"/>
+              </a:rPr>
+              <a:t>   Task Representation Module — branch decoupler</a:t>
+            </a:r>
+          </a:p>
+          <a:p>
+            <a:pPr algn="l">
+              <a:spcAft>
+                <a:spcPts val="200"/>
+              </a:spcAft>
+            </a:pPr>
+            <a:r>
+              <a:rPr sz="950" b="1" i="0">
+                <a:solidFill>
+                  <a:srgbClr val="0F1B3D"/>
+                </a:solidFill>
+                <a:latin typeface="Calibri"/>
+              </a:rPr>
+              <a:t>MQMHA</a:t>
+            </a:r>
+            <a:r>
+              <a:rPr sz="900" b="0" i="0">
+                <a:solidFill>
+                  <a:srgbClr val="404856"/>
+                </a:solidFill>
+                <a:latin typeface="Calibri"/>
+              </a:rPr>
+              <a:t>   Multi-Query Multi-Head Attention pooling</a:t>
+            </a:r>
+          </a:p>
+          <a:p>
+            <a:pPr algn="l">
+              <a:spcAft>
+                <a:spcPts val="200"/>
+              </a:spcAft>
+            </a:pPr>
+            <a:r>
+              <a:rPr sz="950" b="1" i="0">
+                <a:solidFill>
+                  <a:srgbClr val="0F1B3D"/>
+                </a:solidFill>
+                <a:latin typeface="Calibri"/>
+              </a:rPr>
+              <a:t>FiLM</a:t>
+            </a:r>
+            <a:r>
+              <a:rPr sz="900" b="0" i="0">
+                <a:solidFill>
+                  <a:srgbClr val="404856"/>
+                </a:solidFill>
+                <a:latin typeface="Calibri"/>
+              </a:rPr>
+              <a:t>   Feature-wise Linear Modulation (γ scale + β shift)</a:t>
+            </a:r>
+          </a:p>
+          <a:p>
+            <a:pPr algn="l">
+              <a:spcAft>
+                <a:spcPts val="200"/>
+              </a:spcAft>
+            </a:pPr>
+            <a:r>
+              <a:rPr sz="950" b="1" i="0">
+                <a:solidFill>
+                  <a:srgbClr val="0F1B3D"/>
+                </a:solidFill>
+                <a:latin typeface="Calibri"/>
+              </a:rPr>
+              <a:t>stop-grad</a:t>
+            </a:r>
+            <a:r>
+              <a:rPr sz="900" b="0" i="0">
+                <a:solidFill>
+                  <a:srgbClr val="404856"/>
+                </a:solidFill>
+                <a:latin typeface="Calibri"/>
+              </a:rPr>
+              <a:t>   edge that blocks back-propagation</a:t>
+            </a:r>
+          </a:p>
+        </p:txBody>
+      </p:sp>
+      <p:sp>
+        <p:nvSpPr>
+          <p:cNvPr id="9" name="Rounded Rectangle 8"/>
+          <p:cNvSpPr/>
+          <p:nvPr/>
+        </p:nvSpPr>
+        <p:spPr>
+          <a:xfrm>
+            <a:off x="4279391" y="960120"/>
+            <a:ext cx="3749039" cy="2697480"/>
+          </a:xfrm>
+          <a:prstGeom prst="roundRect">
+            <a:avLst>
+              <a:gd name="adj" fmla="val 6000"/>
+            </a:avLst>
+          </a:prstGeom>
+          <a:solidFill>
+            <a:srgbClr val="FDEEEE"/>
+          </a:solidFill>
+          <a:ln w="9525">
+            <a:solidFill>
+              <a:srgbClr val="C3292B"/>
+            </a:solidFill>
+          </a:ln>
+        </p:spPr>
+        <p:style>
+          <a:lnRef idx="1">
+            <a:schemeClr val="accent1"/>
+          </a:lnRef>
+          <a:fillRef idx="3">
+            <a:schemeClr val="accent1"/>
+          </a:fillRef>
+          <a:effectRef idx="2">
+            <a:schemeClr val="accent1"/>
+          </a:effectRef>
+          <a:fontRef idx="minor">
+            <a:schemeClr val="lt1"/>
+          </a:fontRef>
+        </p:style>
+        <p:txBody>
+          <a:bodyPr rtlCol="0" anchor="ctr"/>
+          <a:lstStyle/>
+          <a:p/>
+        </p:txBody>
+      </p:sp>
+      <p:sp>
+        <p:nvSpPr>
+          <p:cNvPr id="10" name="TextBox 9"/>
+          <p:cNvSpPr txBox="1"/>
+          <p:nvPr/>
+        </p:nvSpPr>
+        <p:spPr>
+          <a:xfrm>
+            <a:off x="4443983" y="1033272"/>
+            <a:ext cx="3419855" cy="292608"/>
+          </a:xfrm>
+          <a:prstGeom prst="rect">
+            <a:avLst/>
+          </a:prstGeom>
+          <a:noFill/>
+        </p:spPr>
+        <p:txBody>
+          <a:bodyPr wrap="square" lIns="73152" rIns="73152" tIns="43891" bIns="43891" anchor="t">
+            <a:spAutoFit/>
+          </a:bodyPr>
+          <a:lstStyle/>
+          <a:p>
+            <a:pPr algn="l"/>
+            <a:r>
+              <a:rPr sz="1200" b="1" i="0">
+                <a:solidFill>
+                  <a:srgbClr val="C3292B"/>
+                </a:solidFill>
+                <a:latin typeface="Calibri"/>
+              </a:rPr>
+              <a:t>Losses &amp; Training</a:t>
+            </a:r>
+          </a:p>
+        </p:txBody>
+      </p:sp>
+      <p:sp>
+        <p:nvSpPr>
+          <p:cNvPr id="11" name="TextBox 10"/>
+          <p:cNvSpPr txBox="1"/>
+          <p:nvPr/>
+        </p:nvSpPr>
+        <p:spPr>
+          <a:xfrm>
+            <a:off x="4462271" y="1362456"/>
+            <a:ext cx="3383279" cy="2194560"/>
+          </a:xfrm>
+          <a:prstGeom prst="rect">
+            <a:avLst/>
+          </a:prstGeom>
+          <a:noFill/>
+        </p:spPr>
+        <p:txBody>
+          <a:bodyPr wrap="square" lIns="36576" rIns="36576" tIns="21945" bIns="21945" anchor="t">
+            <a:spAutoFit/>
+          </a:bodyPr>
+          <a:lstStyle/>
+          <a:p>
+            <a:pPr algn="l">
+              <a:spcAft>
+                <a:spcPts val="200"/>
+              </a:spcAft>
+            </a:pPr>
+            <a:r>
+              <a:rPr sz="950" b="1" i="0">
+                <a:solidFill>
+                  <a:srgbClr val="0F1B3D"/>
+                </a:solidFill>
+                <a:latin typeface="Calibri"/>
+              </a:rPr>
+              <a:t>KD</a:t>
+            </a:r>
+            <a:r>
+              <a:rPr sz="900" b="0" i="0">
+                <a:solidFill>
+                  <a:srgbClr val="404856"/>
+                </a:solidFill>
+                <a:latin typeface="Calibri"/>
+              </a:rPr>
+              <a:t>   Knowledge Distillation</a:t>
+            </a:r>
+          </a:p>
+          <a:p>
+            <a:pPr algn="l">
+              <a:spcAft>
+                <a:spcPts val="200"/>
+              </a:spcAft>
+            </a:pPr>
+            <a:r>
+              <a:rPr sz="950" b="1" i="0">
+                <a:solidFill>
+                  <a:srgbClr val="0F1B3D"/>
+                </a:solidFill>
+                <a:latin typeface="Calibri"/>
+              </a:rPr>
+              <a:t>Focal CE</a:t>
+            </a:r>
+            <a:r>
+              <a:rPr sz="900" b="0" i="0">
+                <a:solidFill>
+                  <a:srgbClr val="404856"/>
+                </a:solidFill>
+                <a:latin typeface="Calibri"/>
+              </a:rPr>
+              <a:t>   Focal Cross-Entropy</a:t>
+            </a:r>
+          </a:p>
+          <a:p>
+            <a:pPr algn="l">
+              <a:spcAft>
+                <a:spcPts val="200"/>
+              </a:spcAft>
+            </a:pPr>
+            <a:r>
+              <a:rPr sz="950" b="1" i="0">
+                <a:solidFill>
+                  <a:srgbClr val="0F1B3D"/>
+                </a:solidFill>
+                <a:latin typeface="Calibri"/>
+              </a:rPr>
+              <a:t>AAM-Softmax</a:t>
+            </a:r>
+            <a:r>
+              <a:rPr sz="900" b="0" i="0">
+                <a:solidFill>
+                  <a:srgbClr val="404856"/>
+                </a:solidFill>
+                <a:latin typeface="Calibri"/>
+              </a:rPr>
+              <a:t>   Additive Angular Margin Softmax</a:t>
+            </a:r>
+          </a:p>
+          <a:p>
+            <a:pPr algn="l">
+              <a:spcAft>
+                <a:spcPts val="200"/>
+              </a:spcAft>
+            </a:pPr>
+            <a:r>
+              <a:rPr sz="950" b="1" i="0">
+                <a:solidFill>
+                  <a:srgbClr val="0F1B3D"/>
+                </a:solidFill>
+                <a:latin typeface="Calibri"/>
+              </a:rPr>
+              <a:t>Sub-center</a:t>
+            </a:r>
+            <a:r>
+              <a:rPr sz="900" b="0" i="0">
+                <a:solidFill>
+                  <a:srgbClr val="404856"/>
+                </a:solidFill>
+                <a:latin typeface="Calibri"/>
+              </a:rPr>
+              <a:t>   AAM variant — handles label noise (K=3 cones)</a:t>
+            </a:r>
+          </a:p>
+          <a:p>
+            <a:pPr algn="l">
+              <a:spcAft>
+                <a:spcPts val="200"/>
+              </a:spcAft>
+            </a:pPr>
+            <a:r>
+              <a:rPr sz="950" b="1" i="0">
+                <a:solidFill>
+                  <a:srgbClr val="0F1B3D"/>
+                </a:solidFill>
+                <a:latin typeface="Calibri"/>
+              </a:rPr>
+              <a:t>KL</a:t>
+            </a:r>
+            <a:r>
+              <a:rPr sz="900" b="0" i="0">
+                <a:solidFill>
+                  <a:srgbClr val="404856"/>
+                </a:solidFill>
+                <a:latin typeface="Calibri"/>
+              </a:rPr>
+              <a:t>   Kullback–Leibler divergence</a:t>
+            </a:r>
+          </a:p>
+          <a:p>
+            <a:pPr algn="l">
+              <a:spcAft>
+                <a:spcPts val="200"/>
+              </a:spcAft>
+            </a:pPr>
+            <a:r>
+              <a:rPr sz="950" b="1" i="0">
+                <a:solidFill>
+                  <a:srgbClr val="0F1B3D"/>
+                </a:solidFill>
+                <a:latin typeface="Calibri"/>
+              </a:rPr>
+              <a:t>L_hint</a:t>
+            </a:r>
+            <a:r>
+              <a:rPr sz="900" b="0" i="0">
+                <a:solidFill>
+                  <a:srgbClr val="404856"/>
+                </a:solidFill>
+                <a:latin typeface="Calibri"/>
+              </a:rPr>
+              <a:t>   feature-matching distillation loss</a:t>
+            </a:r>
+          </a:p>
+          <a:p>
+            <a:pPr algn="l">
+              <a:spcAft>
+                <a:spcPts val="200"/>
+              </a:spcAft>
+            </a:pPr>
+            <a:r>
+              <a:rPr sz="950" b="1" i="0">
+                <a:solidFill>
+                  <a:srgbClr val="0F1B3D"/>
+                </a:solidFill>
+                <a:latin typeface="Calibri"/>
+              </a:rPr>
+              <a:t>T,  λᵢ,  m</a:t>
+            </a:r>
+            <a:r>
+              <a:rPr sz="900" b="0" i="0">
+                <a:solidFill>
+                  <a:srgbClr val="404856"/>
+                </a:solidFill>
+                <a:latin typeface="Calibri"/>
+              </a:rPr>
+              <a:t>   distill temperature  ·  loss weights  ·  margin</a:t>
+            </a:r>
+          </a:p>
+          <a:p>
+            <a:pPr algn="l">
+              <a:spcAft>
+                <a:spcPts val="200"/>
+              </a:spcAft>
+            </a:pPr>
+            <a:r>
+              <a:rPr sz="950" b="1" i="0">
+                <a:solidFill>
+                  <a:srgbClr val="0F1B3D"/>
+                </a:solidFill>
+                <a:latin typeface="Calibri"/>
+              </a:rPr>
+              <a:t>GRL</a:t>
+            </a:r>
+            <a:r>
+              <a:rPr sz="900" b="0" i="0">
+                <a:solidFill>
+                  <a:srgbClr val="404856"/>
+                </a:solidFill>
+                <a:latin typeface="Calibri"/>
+              </a:rPr>
+              <a:t>   Gradient Reversal Layer</a:t>
+            </a:r>
+          </a:p>
+        </p:txBody>
+      </p:sp>
+      <p:sp>
+        <p:nvSpPr>
+          <p:cNvPr id="12" name="Rounded Rectangle 11"/>
+          <p:cNvSpPr/>
+          <p:nvPr/>
+        </p:nvSpPr>
+        <p:spPr>
+          <a:xfrm>
+            <a:off x="8147302" y="960120"/>
+            <a:ext cx="3749039" cy="2697480"/>
+          </a:xfrm>
+          <a:prstGeom prst="roundRect">
+            <a:avLst>
+              <a:gd name="adj" fmla="val 6000"/>
+            </a:avLst>
+          </a:prstGeom>
+          <a:solidFill>
+            <a:srgbClr val="E7F4EC"/>
+          </a:solidFill>
+          <a:ln w="9525">
+            <a:solidFill>
+              <a:srgbClr val="1B7F4F"/>
+            </a:solidFill>
+          </a:ln>
+        </p:spPr>
+        <p:style>
+          <a:lnRef idx="1">
+            <a:schemeClr val="accent1"/>
+          </a:lnRef>
+          <a:fillRef idx="3">
+            <a:schemeClr val="accent1"/>
+          </a:fillRef>
+          <a:effectRef idx="2">
+            <a:schemeClr val="accent1"/>
+          </a:effectRef>
+          <a:fontRef idx="minor">
+            <a:schemeClr val="lt1"/>
+          </a:fontRef>
+        </p:style>
+        <p:txBody>
+          <a:bodyPr rtlCol="0" anchor="ctr"/>
+          <a:lstStyle/>
+          <a:p/>
+        </p:txBody>
+      </p:sp>
+      <p:sp>
+        <p:nvSpPr>
+          <p:cNvPr id="13" name="TextBox 12"/>
+          <p:cNvSpPr txBox="1"/>
+          <p:nvPr/>
+        </p:nvSpPr>
+        <p:spPr>
+          <a:xfrm>
+            <a:off x="8311894" y="1033272"/>
+            <a:ext cx="3419855" cy="292608"/>
+          </a:xfrm>
+          <a:prstGeom prst="rect">
+            <a:avLst/>
+          </a:prstGeom>
+          <a:noFill/>
+        </p:spPr>
+        <p:txBody>
+          <a:bodyPr wrap="square" lIns="73152" rIns="73152" tIns="43891" bIns="43891" anchor="t">
+            <a:spAutoFit/>
+          </a:bodyPr>
+          <a:lstStyle/>
+          <a:p>
+            <a:pPr algn="l"/>
+            <a:r>
+              <a:rPr sz="1200" b="1" i="0">
+                <a:solidFill>
+                  <a:srgbClr val="1B7F4F"/>
+                </a:solidFill>
+                <a:latin typeface="Calibri"/>
+              </a:rPr>
+              <a:t>Metrics</a:t>
+            </a:r>
+          </a:p>
+        </p:txBody>
+      </p:sp>
+      <p:sp>
+        <p:nvSpPr>
+          <p:cNvPr id="14" name="TextBox 13"/>
+          <p:cNvSpPr txBox="1"/>
+          <p:nvPr/>
+        </p:nvSpPr>
+        <p:spPr>
+          <a:xfrm>
+            <a:off x="8330182" y="1362456"/>
+            <a:ext cx="3383279" cy="2194560"/>
+          </a:xfrm>
+          <a:prstGeom prst="rect">
+            <a:avLst/>
+          </a:prstGeom>
+          <a:noFill/>
+        </p:spPr>
+        <p:txBody>
+          <a:bodyPr wrap="square" lIns="36576" rIns="36576" tIns="21945" bIns="21945" anchor="t">
+            <a:spAutoFit/>
+          </a:bodyPr>
+          <a:lstStyle/>
+          <a:p>
+            <a:pPr algn="l">
+              <a:spcAft>
+                <a:spcPts val="200"/>
+              </a:spcAft>
+            </a:pPr>
+            <a:r>
+              <a:rPr sz="950" b="1" i="0">
+                <a:solidFill>
+                  <a:srgbClr val="0F1B3D"/>
+                </a:solidFill>
+                <a:latin typeface="Calibri"/>
+              </a:rPr>
+              <a:t>KWS, SV</a:t>
+            </a:r>
+            <a:r>
+              <a:rPr sz="900" b="0" i="0">
+                <a:solidFill>
+                  <a:srgbClr val="404856"/>
+                </a:solidFill>
+                <a:latin typeface="Calibri"/>
+              </a:rPr>
+              <a:t>   Keyword Spotting  ·  Speaker Verification</a:t>
+            </a:r>
+          </a:p>
+          <a:p>
+            <a:pPr algn="l">
+              <a:spcAft>
+                <a:spcPts val="200"/>
+              </a:spcAft>
+            </a:pPr>
+            <a:r>
+              <a:rPr sz="950" b="1" i="0">
+                <a:solidFill>
+                  <a:srgbClr val="0F1B3D"/>
+                </a:solidFill>
+                <a:latin typeface="Calibri"/>
+              </a:rPr>
+              <a:t>TA / FA</a:t>
+            </a:r>
+            <a:r>
+              <a:rPr sz="900" b="0" i="0">
+                <a:solidFill>
+                  <a:srgbClr val="404856"/>
+                </a:solidFill>
+                <a:latin typeface="Calibri"/>
+              </a:rPr>
+              <a:t>   True / False Acceptance (event)</a:t>
+            </a:r>
+          </a:p>
+          <a:p>
+            <a:pPr algn="l">
+              <a:spcAft>
+                <a:spcPts val="200"/>
+              </a:spcAft>
+            </a:pPr>
+            <a:r>
+              <a:rPr sz="950" b="1" i="0">
+                <a:solidFill>
+                  <a:srgbClr val="0F1B3D"/>
+                </a:solidFill>
+                <a:latin typeface="Calibri"/>
+              </a:rPr>
+              <a:t>TAR / FAR</a:t>
+            </a:r>
+            <a:r>
+              <a:rPr sz="900" b="0" i="0">
+                <a:solidFill>
+                  <a:srgbClr val="404856"/>
+                </a:solidFill>
+                <a:latin typeface="Calibri"/>
+              </a:rPr>
+              <a:t>   True / False Acceptance Rate (%)</a:t>
+            </a:r>
+          </a:p>
+          <a:p>
+            <a:pPr algn="l">
+              <a:spcAft>
+                <a:spcPts val="200"/>
+              </a:spcAft>
+            </a:pPr>
+            <a:r>
+              <a:rPr sz="950" b="1" i="0">
+                <a:solidFill>
+                  <a:srgbClr val="0F1B3D"/>
+                </a:solidFill>
+                <a:latin typeface="Calibri"/>
+              </a:rPr>
+              <a:t>FRR</a:t>
+            </a:r>
+            <a:r>
+              <a:rPr sz="900" b="0" i="0">
+                <a:solidFill>
+                  <a:srgbClr val="404856"/>
+                </a:solidFill>
+                <a:latin typeface="Calibri"/>
+              </a:rPr>
+              <a:t>   False Rejection Rate</a:t>
+            </a:r>
+          </a:p>
+          <a:p>
+            <a:pPr algn="l">
+              <a:spcAft>
+                <a:spcPts val="200"/>
+              </a:spcAft>
+            </a:pPr>
+            <a:r>
+              <a:rPr sz="950" b="1" i="0">
+                <a:solidFill>
+                  <a:srgbClr val="0F1B3D"/>
+                </a:solidFill>
+                <a:latin typeface="Calibri"/>
+              </a:rPr>
+              <a:t>EER</a:t>
+            </a:r>
+            <a:r>
+              <a:rPr sz="900" b="0" i="0">
+                <a:solidFill>
+                  <a:srgbClr val="404856"/>
+                </a:solidFill>
+                <a:latin typeface="Calibri"/>
+              </a:rPr>
+              <a:t>   Equal Error Rate (FAR = FRR crossover)</a:t>
+            </a:r>
+          </a:p>
+          <a:p>
+            <a:pPr algn="l">
+              <a:spcAft>
+                <a:spcPts val="200"/>
+              </a:spcAft>
+            </a:pPr>
+            <a:r>
+              <a:rPr sz="950" b="1" i="0">
+                <a:solidFill>
+                  <a:srgbClr val="0F1B3D"/>
+                </a:solidFill>
+                <a:latin typeface="Calibri"/>
+              </a:rPr>
+              <a:t>AUC</a:t>
+            </a:r>
+            <a:r>
+              <a:rPr sz="900" b="0" i="0">
+                <a:solidFill>
+                  <a:srgbClr val="404856"/>
+                </a:solidFill>
+                <a:latin typeface="Calibri"/>
+              </a:rPr>
+              <a:t>   Area Under ROC Curve</a:t>
+            </a:r>
+          </a:p>
+          <a:p>
+            <a:pPr algn="l">
+              <a:spcAft>
+                <a:spcPts val="200"/>
+              </a:spcAft>
+            </a:pPr>
+            <a:r>
+              <a:rPr sz="950" b="1" i="0">
+                <a:solidFill>
+                  <a:srgbClr val="0F1B3D"/>
+                </a:solidFill>
+                <a:latin typeface="Calibri"/>
+              </a:rPr>
+              <a:t>REJ</a:t>
+            </a:r>
+            <a:r>
+              <a:rPr sz="900" b="0" i="0">
+                <a:solidFill>
+                  <a:srgbClr val="404856"/>
+                </a:solidFill>
+                <a:latin typeface="Calibri"/>
+              </a:rPr>
+              <a:t>   impostor-rejection rate</a:t>
+            </a:r>
+          </a:p>
+          <a:p>
+            <a:pPr algn="l">
+              <a:spcAft>
+                <a:spcPts val="200"/>
+              </a:spcAft>
+            </a:pPr>
+            <a:r>
+              <a:rPr sz="950" b="1" i="0">
+                <a:solidFill>
+                  <a:srgbClr val="0F1B3D"/>
+                </a:solidFill>
+                <a:latin typeface="Calibri"/>
+              </a:rPr>
+              <a:t>pp,  xRT,  SNR</a:t>
+            </a:r>
+            <a:r>
+              <a:rPr sz="900" b="0" i="0">
+                <a:solidFill>
+                  <a:srgbClr val="404856"/>
+                </a:solidFill>
+                <a:latin typeface="Calibri"/>
+              </a:rPr>
+              <a:t>   percentage pts  ·  real-time factor  ·  signal/noise (dB)</a:t>
+            </a:r>
+          </a:p>
+        </p:txBody>
+      </p:sp>
+      <p:sp>
+        <p:nvSpPr>
+          <p:cNvPr id="15" name="Rounded Rectangle 14"/>
+          <p:cNvSpPr/>
+          <p:nvPr/>
+        </p:nvSpPr>
+        <p:spPr>
+          <a:xfrm>
+            <a:off x="411480" y="3776472"/>
+            <a:ext cx="3749039" cy="2697480"/>
+          </a:xfrm>
+          <a:prstGeom prst="roundRect">
+            <a:avLst>
+              <a:gd name="adj" fmla="val 6000"/>
+            </a:avLst>
+          </a:prstGeom>
+          <a:solidFill>
+            <a:srgbClr val="FBF2DD"/>
+          </a:solidFill>
+          <a:ln w="9525">
+            <a:solidFill>
+              <a:srgbClr val="B8860B"/>
+            </a:solidFill>
+          </a:ln>
+        </p:spPr>
+        <p:style>
+          <a:lnRef idx="1">
+            <a:schemeClr val="accent1"/>
+          </a:lnRef>
+          <a:fillRef idx="3">
+            <a:schemeClr val="accent1"/>
+          </a:fillRef>
+          <a:effectRef idx="2">
+            <a:schemeClr val="accent1"/>
+          </a:effectRef>
+          <a:fontRef idx="minor">
+            <a:schemeClr val="lt1"/>
+          </a:fontRef>
+        </p:style>
+        <p:txBody>
+          <a:bodyPr rtlCol="0" anchor="ctr"/>
+          <a:lstStyle/>
+          <a:p/>
+        </p:txBody>
+      </p:sp>
+      <p:sp>
+        <p:nvSpPr>
+          <p:cNvPr id="16" name="TextBox 15"/>
+          <p:cNvSpPr txBox="1"/>
+          <p:nvPr/>
+        </p:nvSpPr>
+        <p:spPr>
+          <a:xfrm>
+            <a:off x="576072" y="3849624"/>
+            <a:ext cx="3419855" cy="292608"/>
+          </a:xfrm>
+          <a:prstGeom prst="rect">
+            <a:avLst/>
+          </a:prstGeom>
+          <a:noFill/>
+        </p:spPr>
+        <p:txBody>
+          <a:bodyPr wrap="square" lIns="73152" rIns="73152" tIns="43891" bIns="43891" anchor="t">
+            <a:spAutoFit/>
+          </a:bodyPr>
+          <a:lstStyle/>
+          <a:p>
+            <a:pPr algn="l"/>
+            <a:r>
+              <a:rPr sz="1200" b="1" i="0">
+                <a:solidFill>
+                  <a:srgbClr val="B8860B"/>
+                </a:solidFill>
+                <a:latin typeface="Calibri"/>
+              </a:rPr>
+              <a:t>Datasets &amp; Models</a:t>
+            </a:r>
+          </a:p>
+        </p:txBody>
+      </p:sp>
+      <p:sp>
+        <p:nvSpPr>
+          <p:cNvPr id="17" name="TextBox 16"/>
+          <p:cNvSpPr txBox="1"/>
+          <p:nvPr/>
+        </p:nvSpPr>
+        <p:spPr>
+          <a:xfrm>
+            <a:off x="594360" y="4178808"/>
+            <a:ext cx="3383279" cy="2194560"/>
+          </a:xfrm>
+          <a:prstGeom prst="rect">
+            <a:avLst/>
+          </a:prstGeom>
+          <a:noFill/>
+        </p:spPr>
+        <p:txBody>
+          <a:bodyPr wrap="square" lIns="36576" rIns="36576" tIns="21945" bIns="21945" anchor="t">
+            <a:spAutoFit/>
+          </a:bodyPr>
+          <a:lstStyle/>
+          <a:p>
+            <a:pPr algn="l">
+              <a:spcAft>
+                <a:spcPts val="200"/>
+              </a:spcAft>
+            </a:pPr>
+            <a:r>
+              <a:rPr sz="950" b="1" i="0">
+                <a:solidFill>
+                  <a:srgbClr val="0F1B3D"/>
+                </a:solidFill>
+                <a:latin typeface="Calibri"/>
+              </a:rPr>
+              <a:t>SC V2</a:t>
+            </a:r>
+            <a:r>
+              <a:rPr sz="900" b="0" i="0">
+                <a:solidFill>
+                  <a:srgbClr val="404856"/>
+                </a:solidFill>
+                <a:latin typeface="Calibri"/>
+              </a:rPr>
+              <a:t>   Google Speech Commands v0.02 (KWS corpus)</a:t>
+            </a:r>
+          </a:p>
+          <a:p>
+            <a:pPr algn="l">
+              <a:spcAft>
+                <a:spcPts val="200"/>
+              </a:spcAft>
+            </a:pPr>
+            <a:r>
+              <a:rPr sz="950" b="1" i="0">
+                <a:solidFill>
+                  <a:srgbClr val="0F1B3D"/>
+                </a:solidFill>
+                <a:latin typeface="Calibri"/>
+              </a:rPr>
+              <a:t>MSWC</a:t>
+            </a:r>
+            <a:r>
+              <a:rPr sz="900" b="0" i="0">
+                <a:solidFill>
+                  <a:srgbClr val="404856"/>
+                </a:solidFill>
+                <a:latin typeface="Calibri"/>
+              </a:rPr>
+              <a:t>   MLCommons Spoken Words Corpus (multilingual)</a:t>
+            </a:r>
+          </a:p>
+          <a:p>
+            <a:pPr algn="l">
+              <a:spcAft>
+                <a:spcPts val="200"/>
+              </a:spcAft>
+            </a:pPr>
+            <a:r>
+              <a:rPr sz="950" b="1" i="0">
+                <a:solidFill>
+                  <a:srgbClr val="0F1B3D"/>
+                </a:solidFill>
+                <a:latin typeface="Calibri"/>
+              </a:rPr>
+              <a:t>VoxCeleb1-O</a:t>
+            </a:r>
+            <a:r>
+              <a:rPr sz="900" b="0" i="0">
+                <a:solidFill>
+                  <a:srgbClr val="404856"/>
+                </a:solidFill>
+                <a:latin typeface="Calibri"/>
+              </a:rPr>
+              <a:t>   Original VoxCeleb1 trial list (37 720 pairs)</a:t>
+            </a:r>
+          </a:p>
+          <a:p>
+            <a:pPr algn="l">
+              <a:spcAft>
+                <a:spcPts val="200"/>
+              </a:spcAft>
+            </a:pPr>
+            <a:r>
+              <a:rPr sz="950" b="1" i="0">
+                <a:solidFill>
+                  <a:srgbClr val="0F1B3D"/>
+                </a:solidFill>
+                <a:latin typeface="Calibri"/>
+              </a:rPr>
+              <a:t>MUSAN</a:t>
+            </a:r>
+            <a:r>
+              <a:rPr sz="900" b="0" i="0">
+                <a:solidFill>
+                  <a:srgbClr val="404856"/>
+                </a:solidFill>
+                <a:latin typeface="Calibri"/>
+              </a:rPr>
+              <a:t>   Music-Speech-Noise corpus (noise augmentation)</a:t>
+            </a:r>
+          </a:p>
+          <a:p>
+            <a:pPr algn="l">
+              <a:spcAft>
+                <a:spcPts val="200"/>
+              </a:spcAft>
+            </a:pPr>
+            <a:r>
+              <a:rPr sz="950" b="1" i="0">
+                <a:solidFill>
+                  <a:srgbClr val="0F1B3D"/>
+                </a:solidFill>
+                <a:latin typeface="Calibri"/>
+              </a:rPr>
+              <a:t>RIR</a:t>
+            </a:r>
+            <a:r>
+              <a:rPr sz="900" b="0" i="0">
+                <a:solidFill>
+                  <a:srgbClr val="404856"/>
+                </a:solidFill>
+                <a:latin typeface="Calibri"/>
+              </a:rPr>
+              <a:t>   Room Impulse Response (far-field simulation)</a:t>
+            </a:r>
+          </a:p>
+          <a:p>
+            <a:pPr algn="l">
+              <a:spcAft>
+                <a:spcPts val="200"/>
+              </a:spcAft>
+            </a:pPr>
+            <a:r>
+              <a:rPr sz="950" b="1" i="0">
+                <a:solidFill>
+                  <a:srgbClr val="0F1B3D"/>
+                </a:solidFill>
+                <a:latin typeface="Calibri"/>
+              </a:rPr>
+              <a:t>WavLM</a:t>
+            </a:r>
+            <a:r>
+              <a:rPr sz="900" b="0" i="0">
+                <a:solidFill>
+                  <a:srgbClr val="404856"/>
+                </a:solidFill>
+                <a:latin typeface="Calibri"/>
+              </a:rPr>
+              <a:t>   Microsoft pretrained speech encoder</a:t>
+            </a:r>
+          </a:p>
+          <a:p>
+            <a:pPr algn="l">
+              <a:spcAft>
+                <a:spcPts val="200"/>
+              </a:spcAft>
+            </a:pPr>
+            <a:r>
+              <a:rPr sz="950" b="1" i="0">
+                <a:solidFill>
+                  <a:srgbClr val="0F1B3D"/>
+                </a:solidFill>
+                <a:latin typeface="Calibri"/>
+              </a:rPr>
+              <a:t>ECAPA-TDNN</a:t>
+            </a:r>
+            <a:r>
+              <a:rPr sz="900" b="0" i="0">
+                <a:solidFill>
+                  <a:srgbClr val="404856"/>
+                </a:solidFill>
+                <a:latin typeface="Calibri"/>
+              </a:rPr>
+              <a:t>   pretrained speaker-verification model</a:t>
+            </a:r>
+          </a:p>
+          <a:p>
+            <a:pPr algn="l">
+              <a:spcAft>
+                <a:spcPts val="200"/>
+              </a:spcAft>
+            </a:pPr>
+            <a:r>
+              <a:rPr sz="950" b="1" i="0">
+                <a:solidFill>
+                  <a:srgbClr val="0F1B3D"/>
+                </a:solidFill>
+                <a:latin typeface="Calibri"/>
+              </a:rPr>
+              <a:t>XTTS-v2 / g2p-en</a:t>
+            </a:r>
+            <a:r>
+              <a:rPr sz="900" b="0" i="0">
+                <a:solidFill>
+                  <a:srgbClr val="404856"/>
+                </a:solidFill>
+                <a:latin typeface="Calibri"/>
+              </a:rPr>
+              <a:t>   Coqui multilingual TTS  ·  English G2P</a:t>
+            </a:r>
+          </a:p>
+        </p:txBody>
+      </p:sp>
+      <p:sp>
+        <p:nvSpPr>
+          <p:cNvPr id="18" name="Rounded Rectangle 17"/>
+          <p:cNvSpPr/>
+          <p:nvPr/>
+        </p:nvSpPr>
+        <p:spPr>
+          <a:xfrm>
+            <a:off x="4279391" y="3776472"/>
+            <a:ext cx="3749039" cy="2697480"/>
+          </a:xfrm>
+          <a:prstGeom prst="roundRect">
+            <a:avLst>
+              <a:gd name="adj" fmla="val 6000"/>
+            </a:avLst>
+          </a:prstGeom>
+          <a:solidFill>
+            <a:srgbClr val="EEF1F7"/>
+          </a:solidFill>
+          <a:ln w="9525">
+            <a:solidFill>
+              <a:srgbClr val="0F1B3D"/>
+            </a:solidFill>
+          </a:ln>
+        </p:spPr>
+        <p:style>
+          <a:lnRef idx="1">
+            <a:schemeClr val="accent1"/>
+          </a:lnRef>
+          <a:fillRef idx="3">
+            <a:schemeClr val="accent1"/>
+          </a:fillRef>
+          <a:effectRef idx="2">
+            <a:schemeClr val="accent1"/>
+          </a:effectRef>
+          <a:fontRef idx="minor">
+            <a:schemeClr val="lt1"/>
+          </a:fontRef>
+        </p:style>
+        <p:txBody>
+          <a:bodyPr rtlCol="0" anchor="ctr"/>
+          <a:lstStyle/>
+          <a:p/>
+        </p:txBody>
+      </p:sp>
+      <p:sp>
+        <p:nvSpPr>
+          <p:cNvPr id="19" name="TextBox 18"/>
+          <p:cNvSpPr txBox="1"/>
+          <p:nvPr/>
+        </p:nvSpPr>
+        <p:spPr>
+          <a:xfrm>
+            <a:off x="4443983" y="3849624"/>
+            <a:ext cx="3419855" cy="292608"/>
+          </a:xfrm>
+          <a:prstGeom prst="rect">
+            <a:avLst/>
+          </a:prstGeom>
+          <a:noFill/>
+        </p:spPr>
+        <p:txBody>
+          <a:bodyPr wrap="square" lIns="73152" rIns="73152" tIns="43891" bIns="43891" anchor="t">
+            <a:spAutoFit/>
+          </a:bodyPr>
+          <a:lstStyle/>
+          <a:p>
+            <a:pPr algn="l"/>
+            <a:r>
+              <a:rPr sz="1200" b="1" i="0">
+                <a:solidFill>
+                  <a:srgbClr val="0F1B3D"/>
+                </a:solidFill>
+                <a:latin typeface="Calibri"/>
+              </a:rPr>
+              <a:t>Deployment</a:t>
+            </a:r>
+          </a:p>
+        </p:txBody>
+      </p:sp>
+      <p:sp>
+        <p:nvSpPr>
+          <p:cNvPr id="20" name="TextBox 19"/>
+          <p:cNvSpPr txBox="1"/>
+          <p:nvPr/>
+        </p:nvSpPr>
+        <p:spPr>
+          <a:xfrm>
+            <a:off x="4462271" y="4178808"/>
+            <a:ext cx="3383279" cy="2194560"/>
+          </a:xfrm>
+          <a:prstGeom prst="rect">
+            <a:avLst/>
+          </a:prstGeom>
+          <a:noFill/>
+        </p:spPr>
+        <p:txBody>
+          <a:bodyPr wrap="square" lIns="36576" rIns="36576" tIns="21945" bIns="21945" anchor="t">
+            <a:spAutoFit/>
+          </a:bodyPr>
+          <a:lstStyle/>
+          <a:p>
+            <a:pPr algn="l">
+              <a:spcAft>
+                <a:spcPts val="200"/>
+              </a:spcAft>
+            </a:pPr>
+            <a:r>
+              <a:rPr sz="950" b="1" i="0">
+                <a:solidFill>
+                  <a:srgbClr val="0F1B3D"/>
+                </a:solidFill>
+                <a:latin typeface="Calibri"/>
+              </a:rPr>
+              <a:t>ONNX</a:t>
+            </a:r>
+            <a:r>
+              <a:rPr sz="900" b="0" i="0">
+                <a:solidFill>
+                  <a:srgbClr val="404856"/>
+                </a:solidFill>
+                <a:latin typeface="Calibri"/>
+              </a:rPr>
+              <a:t>   Open Neural Network Exchange (export format)</a:t>
+            </a:r>
+          </a:p>
+          <a:p>
+            <a:pPr algn="l">
+              <a:spcAft>
+                <a:spcPts val="200"/>
+              </a:spcAft>
+            </a:pPr>
+            <a:r>
+              <a:rPr sz="950" b="1" i="0">
+                <a:solidFill>
+                  <a:srgbClr val="0F1B3D"/>
+                </a:solidFill>
+                <a:latin typeface="Calibri"/>
+              </a:rPr>
+              <a:t>ORT</a:t>
+            </a:r>
+            <a:r>
+              <a:rPr sz="900" b="0" i="0">
+                <a:solidFill>
+                  <a:srgbClr val="404856"/>
+                </a:solidFill>
+                <a:latin typeface="Calibri"/>
+              </a:rPr>
+              <a:t>   ONNX Runtime — inference engine</a:t>
+            </a:r>
+          </a:p>
+          <a:p>
+            <a:pPr algn="l">
+              <a:spcAft>
+                <a:spcPts val="200"/>
+              </a:spcAft>
+            </a:pPr>
+            <a:r>
+              <a:rPr sz="950" b="1" i="0">
+                <a:solidFill>
+                  <a:srgbClr val="0F1B3D"/>
+                </a:solidFill>
+                <a:latin typeface="Calibri"/>
+              </a:rPr>
+              <a:t>PTQ</a:t>
+            </a:r>
+            <a:r>
+              <a:rPr sz="900" b="0" i="0">
+                <a:solidFill>
+                  <a:srgbClr val="404856"/>
+                </a:solidFill>
+                <a:latin typeface="Calibri"/>
+              </a:rPr>
+              <a:t>   Post-Training Quantization</a:t>
+            </a:r>
+          </a:p>
+          <a:p>
+            <a:pPr algn="l">
+              <a:spcAft>
+                <a:spcPts val="200"/>
+              </a:spcAft>
+            </a:pPr>
+            <a:r>
+              <a:rPr sz="950" b="1" i="0">
+                <a:solidFill>
+                  <a:srgbClr val="0F1B3D"/>
+                </a:solidFill>
+                <a:latin typeface="Calibri"/>
+              </a:rPr>
+              <a:t>QAT</a:t>
+            </a:r>
+            <a:r>
+              <a:rPr sz="900" b="0" i="0">
+                <a:solidFill>
+                  <a:srgbClr val="404856"/>
+                </a:solidFill>
+                <a:latin typeface="Calibri"/>
+              </a:rPr>
+              <a:t>   Quantization-Aware Training</a:t>
+            </a:r>
+          </a:p>
+          <a:p>
+            <a:pPr algn="l">
+              <a:spcAft>
+                <a:spcPts val="200"/>
+              </a:spcAft>
+            </a:pPr>
+            <a:r>
+              <a:rPr sz="950" b="1" i="0">
+                <a:solidFill>
+                  <a:srgbClr val="0F1B3D"/>
+                </a:solidFill>
+                <a:latin typeface="Calibri"/>
+              </a:rPr>
+              <a:t>INT8</a:t>
+            </a:r>
+            <a:r>
+              <a:rPr sz="900" b="0" i="0">
+                <a:solidFill>
+                  <a:srgbClr val="404856"/>
+                </a:solidFill>
+                <a:latin typeface="Calibri"/>
+              </a:rPr>
+              <a:t>   8-bit integer (vs FP32)</a:t>
+            </a:r>
+          </a:p>
+          <a:p>
+            <a:pPr algn="l">
+              <a:spcAft>
+                <a:spcPts val="200"/>
+              </a:spcAft>
+            </a:pPr>
+            <a:r>
+              <a:rPr sz="950" b="1" i="0">
+                <a:solidFill>
+                  <a:srgbClr val="0F1B3D"/>
+                </a:solidFill>
+                <a:latin typeface="Calibri"/>
+              </a:rPr>
+              <a:t>Pi 4B</a:t>
+            </a:r>
+            <a:r>
+              <a:rPr sz="900" b="0" i="0">
+                <a:solidFill>
+                  <a:srgbClr val="404856"/>
+                </a:solidFill>
+                <a:latin typeface="Calibri"/>
+              </a:rPr>
+              <a:t>   Raspberry Pi 4 Model B — conservative edge target</a:t>
+            </a:r>
+          </a:p>
+          <a:p>
+            <a:pPr algn="l">
+              <a:spcAft>
+                <a:spcPts val="200"/>
+              </a:spcAft>
+            </a:pPr>
+            <a:r>
+              <a:rPr sz="950" b="1" i="0">
+                <a:solidFill>
+                  <a:srgbClr val="0F1B3D"/>
+                </a:solidFill>
+                <a:latin typeface="Calibri"/>
+              </a:rPr>
+              <a:t>QNN</a:t>
+            </a:r>
+            <a:r>
+              <a:rPr sz="900" b="0" i="0">
+                <a:solidFill>
+                  <a:srgbClr val="404856"/>
+                </a:solidFill>
+                <a:latin typeface="Calibri"/>
+              </a:rPr>
+              <a:t>   Qualcomm Neural Network SDK</a:t>
+            </a:r>
+          </a:p>
+          <a:p>
+            <a:pPr algn="l">
+              <a:spcAft>
+                <a:spcPts val="200"/>
+              </a:spcAft>
+            </a:pPr>
+            <a:r>
+              <a:rPr sz="950" b="1" i="0">
+                <a:solidFill>
+                  <a:srgbClr val="0F1B3D"/>
+                </a:solidFill>
+                <a:latin typeface="Calibri"/>
+              </a:rPr>
+              <a:t>NPU</a:t>
+            </a:r>
+            <a:r>
+              <a:rPr sz="900" b="0" i="0">
+                <a:solidFill>
+                  <a:srgbClr val="404856"/>
+                </a:solidFill>
+                <a:latin typeface="Calibri"/>
+              </a:rPr>
+              <a:t>   Neural Processing Unit (on-device accelerator)</a:t>
+            </a:r>
+          </a:p>
+        </p:txBody>
+      </p:sp>
+      <p:sp>
+        <p:nvSpPr>
+          <p:cNvPr id="21" name="Rounded Rectangle 20"/>
+          <p:cNvSpPr/>
+          <p:nvPr/>
+        </p:nvSpPr>
+        <p:spPr>
+          <a:xfrm>
+            <a:off x="8147302" y="3776472"/>
+            <a:ext cx="3749039" cy="2697480"/>
+          </a:xfrm>
+          <a:prstGeom prst="roundRect">
+            <a:avLst>
+              <a:gd name="adj" fmla="val 6000"/>
+            </a:avLst>
+          </a:prstGeom>
+          <a:solidFill>
+            <a:srgbClr val="ECF2FC"/>
+          </a:solidFill>
+          <a:ln w="9525">
+            <a:solidFill>
+              <a:srgbClr val="144BC4"/>
+            </a:solidFill>
+          </a:ln>
+        </p:spPr>
+        <p:style>
+          <a:lnRef idx="1">
+            <a:schemeClr val="accent1"/>
+          </a:lnRef>
+          <a:fillRef idx="3">
+            <a:schemeClr val="accent1"/>
+          </a:fillRef>
+          <a:effectRef idx="2">
+            <a:schemeClr val="accent1"/>
+          </a:effectRef>
+          <a:fontRef idx="minor">
+            <a:schemeClr val="lt1"/>
+          </a:fontRef>
+        </p:style>
+        <p:txBody>
+          <a:bodyPr rtlCol="0" anchor="ctr"/>
+          <a:lstStyle/>
+          <a:p/>
+        </p:txBody>
+      </p:sp>
+      <p:sp>
+        <p:nvSpPr>
+          <p:cNvPr id="22" name="TextBox 21"/>
+          <p:cNvSpPr txBox="1"/>
+          <p:nvPr/>
+        </p:nvSpPr>
+        <p:spPr>
+          <a:xfrm>
+            <a:off x="8311894" y="3849624"/>
+            <a:ext cx="3419855" cy="292608"/>
+          </a:xfrm>
+          <a:prstGeom prst="rect">
+            <a:avLst/>
+          </a:prstGeom>
+          <a:noFill/>
+        </p:spPr>
+        <p:txBody>
+          <a:bodyPr wrap="square" lIns="73152" rIns="73152" tIns="43891" bIns="43891" anchor="t">
+            <a:spAutoFit/>
+          </a:bodyPr>
+          <a:lstStyle/>
+          <a:p>
+            <a:pPr algn="l"/>
+            <a:r>
+              <a:rPr sz="1200" b="1" i="0">
+                <a:solidFill>
+                  <a:srgbClr val="144BC4"/>
+                </a:solidFill>
+                <a:latin typeface="Calibri"/>
+              </a:rPr>
+              <a:t>Cited Work &amp; Misc</a:t>
+            </a:r>
+          </a:p>
+        </p:txBody>
+      </p:sp>
+      <p:sp>
+        <p:nvSpPr>
+          <p:cNvPr id="23" name="TextBox 22"/>
+          <p:cNvSpPr txBox="1"/>
+          <p:nvPr/>
+        </p:nvSpPr>
+        <p:spPr>
+          <a:xfrm>
+            <a:off x="8330182" y="4178808"/>
+            <a:ext cx="3383279" cy="2194560"/>
+          </a:xfrm>
+          <a:prstGeom prst="rect">
+            <a:avLst/>
+          </a:prstGeom>
+          <a:noFill/>
+        </p:spPr>
+        <p:txBody>
+          <a:bodyPr wrap="square" lIns="36576" rIns="36576" tIns="21945" bIns="21945" anchor="t">
+            <a:spAutoFit/>
+          </a:bodyPr>
+          <a:lstStyle/>
+          <a:p>
+            <a:pPr algn="l">
+              <a:spcAft>
+                <a:spcPts val="200"/>
+              </a:spcAft>
+            </a:pPr>
+            <a:r>
+              <a:rPr sz="950" b="1" i="0">
+                <a:solidFill>
+                  <a:srgbClr val="0F1B3D"/>
+                </a:solidFill>
+                <a:latin typeface="Calibri"/>
+              </a:rPr>
+              <a:t>SKILL</a:t>
+            </a:r>
+            <a:r>
+              <a:rPr sz="900" b="0" i="0">
+                <a:solidFill>
+                  <a:srgbClr val="404856"/>
+                </a:solidFill>
+                <a:latin typeface="Calibri"/>
+              </a:rPr>
+              <a:t>   layer-ensemble distillation, Interspeech 2024</a:t>
+            </a:r>
+          </a:p>
+          <a:p>
+            <a:pPr algn="l">
+              <a:spcAft>
+                <a:spcPts val="200"/>
+              </a:spcAft>
+            </a:pPr>
+            <a:r>
+              <a:rPr sz="950" b="1" i="0">
+                <a:solidFill>
+                  <a:srgbClr val="0F1B3D"/>
+                </a:solidFill>
+                <a:latin typeface="Calibri"/>
+              </a:rPr>
+              <a:t>PK-MTL</a:t>
+            </a:r>
+            <a:r>
+              <a:rPr sz="900" b="0" i="0">
+                <a:solidFill>
+                  <a:srgbClr val="404856"/>
+                </a:solidFill>
+                <a:latin typeface="Calibri"/>
+              </a:rPr>
+              <a:t>   Per-Keyword Multi-Task Learning  (arXiv:2206.13708)</a:t>
+            </a:r>
+          </a:p>
+          <a:p>
+            <a:pPr algn="l">
+              <a:spcAft>
+                <a:spcPts val="200"/>
+              </a:spcAft>
+            </a:pPr>
+            <a:r>
+              <a:rPr sz="950" b="1" i="0">
+                <a:solidFill>
+                  <a:srgbClr val="0F1B3D"/>
+                </a:solidFill>
+                <a:latin typeface="Calibri"/>
+              </a:rPr>
+              <a:t>GE2E</a:t>
+            </a:r>
+            <a:r>
+              <a:rPr sz="900" b="0" i="0">
+                <a:solidFill>
+                  <a:srgbClr val="404856"/>
+                </a:solidFill>
+                <a:latin typeface="Calibri"/>
+              </a:rPr>
+              <a:t>   Generalized End-to-End speaker loss</a:t>
+            </a:r>
+          </a:p>
+          <a:p>
+            <a:pPr algn="l">
+              <a:spcAft>
+                <a:spcPts val="200"/>
+              </a:spcAft>
+            </a:pPr>
+            <a:r>
+              <a:rPr sz="950" b="1" i="0">
+                <a:solidFill>
+                  <a:srgbClr val="0F1B3D"/>
+                </a:solidFill>
+                <a:latin typeface="Calibri"/>
+              </a:rPr>
+              <a:t>TPE</a:t>
+            </a:r>
+            <a:r>
+              <a:rPr sz="900" b="0" i="0">
+                <a:solidFill>
+                  <a:srgbClr val="404856"/>
+                </a:solidFill>
+                <a:latin typeface="Calibri"/>
+              </a:rPr>
+              <a:t>   Tree-structured Parzen Estimator (Optuna sampler)</a:t>
+            </a:r>
+          </a:p>
+          <a:p>
+            <a:pPr algn="l">
+              <a:spcAft>
+                <a:spcPts val="200"/>
+              </a:spcAft>
+            </a:pPr>
+            <a:r>
+              <a:rPr sz="950" b="1" i="0">
+                <a:solidFill>
+                  <a:srgbClr val="0F1B3D"/>
+                </a:solidFill>
+                <a:latin typeface="Calibri"/>
+              </a:rPr>
+              <a:t>LLM</a:t>
+            </a:r>
+            <a:r>
+              <a:rPr sz="900" b="0" i="0">
+                <a:solidFill>
+                  <a:srgbClr val="404856"/>
+                </a:solidFill>
+                <a:latin typeface="Calibri"/>
+              </a:rPr>
+              <a:t>   Large Language Model</a:t>
+            </a:r>
+          </a:p>
+          <a:p>
+            <a:pPr algn="l">
+              <a:spcAft>
+                <a:spcPts val="200"/>
+              </a:spcAft>
+            </a:pPr>
+            <a:r>
+              <a:rPr sz="950" b="1" i="0">
+                <a:solidFill>
+                  <a:srgbClr val="0F1B3D"/>
+                </a:solidFill>
+                <a:latin typeface="Calibri"/>
+              </a:rPr>
+              <a:t>τₛ</a:t>
+            </a:r>
+            <a:r>
+              <a:rPr sz="900" b="0" i="0">
+                <a:solidFill>
+                  <a:srgbClr val="404856"/>
+                </a:solidFill>
+                <a:latin typeface="Calibri"/>
+              </a:rPr>
+              <a:t>   speaker decision threshold (FAR-in-the-Loop target)</a:t>
+            </a:r>
+          </a:p>
+          <a:p>
+            <a:pPr algn="l">
+              <a:spcAft>
+                <a:spcPts val="200"/>
+              </a:spcAft>
+            </a:pPr>
+            <a:r>
+              <a:rPr sz="950" b="1" i="0">
+                <a:solidFill>
+                  <a:srgbClr val="0F1B3D"/>
+                </a:solidFill>
+                <a:latin typeface="Calibri"/>
+              </a:rPr>
+              <a:t>Apache-2.0, CC-BY, MIT, CPML</a:t>
+            </a:r>
+            <a:r>
+              <a:rPr sz="900" b="0" i="0">
+                <a:solidFill>
+                  <a:srgbClr val="404856"/>
+                </a:solidFill>
+                <a:latin typeface="Calibri"/>
+              </a:rPr>
+              <a:t>   open-source licence shorthands</a:t>
+            </a:r>
+          </a:p>
+        </p:txBody>
+      </p:sp>
+      <p:sp>
+        <p:nvSpPr>
+          <p:cNvPr id="24" name="TextBox 23"/>
+          <p:cNvSpPr txBox="1"/>
+          <p:nvPr/>
+        </p:nvSpPr>
+        <p:spPr>
+          <a:xfrm>
+            <a:off x="411480" y="6565392"/>
+            <a:ext cx="11368735" cy="256032"/>
+          </a:xfrm>
+          <a:prstGeom prst="rect">
+            <a:avLst/>
+          </a:prstGeom>
+          <a:noFill/>
+        </p:spPr>
+        <p:txBody>
+          <a:bodyPr wrap="square" lIns="73152" rIns="73152" tIns="43891" bIns="43891" anchor="t">
+            <a:spAutoFit/>
+          </a:bodyPr>
+          <a:lstStyle/>
+          <a:p>
+            <a:pPr algn="ctr"/>
+            <a:r>
+              <a:rPr sz="900" b="0" i="1">
+                <a:solidFill>
+                  <a:srgbClr val="6A7383"/>
+                </a:solidFill>
+                <a:latin typeface="Calibri"/>
+              </a:rPr>
+              <a:t>Reference appendix — terms used across Slides 2–17. Bolded acronym  ·  full expansion  ·  context.</a:t>
+            </a:r>
+          </a:p>
+        </p:txBody>
+      </p:sp>
+    </p:spTree>
+  </p:cSld>
+  <p:clrMapOvr>
+    <a:masterClrMapping/>
+  </p:clrMapOvr>
+</p:sld>
+</file>
+
 <file path=ppt/slides/slide2.xml><?xml version="1.0" encoding="utf-8"?>
 <p:sld xmlns:a="http://schemas.openxmlformats.org/drawingml/2006/main" xmlns:p="http://schemas.openxmlformats.org/presentationml/2006/main" xmlns:r="http://schemas.openxmlformats.org/officeDocument/2006/relationships">
   <p:cSld>
@@ -10346,7 +12311,7 @@
                 </a:solidFill>
                 <a:latin typeface="Calibri"/>
               </a:rPr>
-              <a:t>2 / 17</a:t>
+              <a:t>2 / 18</a:t>
             </a:r>
           </a:p>
         </p:txBody>
@@ -11302,7 +13267,7 @@
                 </a:solidFill>
                 <a:latin typeface="Calibri"/>
               </a:rPr>
-              <a:t>3 / 17</a:t>
+              <a:t>3 / 18</a:t>
             </a:r>
           </a:p>
         </p:txBody>
@@ -12152,7 +14117,7 @@
                 </a:solidFill>
                 <a:latin typeface="Calibri"/>
               </a:rPr>
-              <a:t>4 / 17</a:t>
+              <a:t>4 / 18</a:t>
             </a:r>
           </a:p>
         </p:txBody>
@@ -12859,7 +14824,7 @@
                 </a:solidFill>
                 <a:latin typeface="Calibri"/>
               </a:rPr>
-              <a:t>5 / 17</a:t>
+              <a:t>5 / 18</a:t>
             </a:r>
           </a:p>
         </p:txBody>
@@ -13279,7 +15244,7 @@
                 </a:solidFill>
                 <a:latin typeface="Calibri"/>
               </a:rPr>
-              <a:t>6 / 17</a:t>
+              <a:t>6 / 18</a:t>
             </a:r>
           </a:p>
         </p:txBody>
@@ -14411,7 +16376,7 @@
                 </a:solidFill>
                 <a:latin typeface="Calibri"/>
               </a:rPr>
-              <a:t>7 / 17</a:t>
+              <a:t>7 / 18</a:t>
             </a:r>
           </a:p>
         </p:txBody>
@@ -15218,7 +17183,7 @@
                 </a:solidFill>
                 <a:latin typeface="Calibri"/>
               </a:rPr>
-              <a:t>8 / 17</a:t>
+              <a:t>8 / 18</a:t>
             </a:r>
           </a:p>
         </p:txBody>
@@ -15799,7 +17764,7 @@
                 </a:solidFill>
                 <a:latin typeface="Calibri"/>
               </a:rPr>
-              <a:t>9 / 17</a:t>
+              <a:t>9 / 18</a:t>
             </a:r>
           </a:p>
         </p:txBody>

</xml_diff>